<commit_message>
Fix chart title/subtitle overlap and rebuild deck
</commit_message>
<xml_diff>
--- a/presentation/Liver_Support_ICU_Keynote.pptx
+++ b/presentation/Liver_Support_ICU_Keynote.pptx
@@ -3869,7 +3869,7 @@
         <p:spPr>
           <a:xfrm>
             <a:off x="2331720" y="1828800"/>
-            <a:ext cx="7448395" cy="4069080"/>
+            <a:ext cx="7955408" cy="4069080"/>
           </a:xfrm>
           <a:prstGeom prst="rect">
             <a:avLst/>
@@ -5690,7 +5690,7 @@
         <p:spPr>
           <a:xfrm>
             <a:off x="457200" y="1828800"/>
-            <a:ext cx="7040880" cy="4618934"/>
+            <a:ext cx="7040880" cy="4578033"/>
           </a:xfrm>
           <a:prstGeom prst="rect">
             <a:avLst/>
@@ -6378,7 +6378,7 @@
         <p:spPr>
           <a:xfrm>
             <a:off x="640080" y="1783080"/>
-            <a:ext cx="6035040" cy="3681657"/>
+            <a:ext cx="6035040" cy="3487086"/>
           </a:xfrm>
           <a:prstGeom prst="rect">
             <a:avLst/>
@@ -8143,7 +8143,7 @@
         <p:spPr>
           <a:xfrm>
             <a:off x="548640" y="1828800"/>
-            <a:ext cx="6583680" cy="4313994"/>
+            <a:ext cx="6583680" cy="4268919"/>
           </a:xfrm>
           <a:prstGeom prst="rect">
             <a:avLst/>
@@ -9644,7 +9644,7 @@
         <p:spPr>
           <a:xfrm>
             <a:off x="457200" y="1828800"/>
-            <a:ext cx="7680960" cy="4888147"/>
+            <a:ext cx="7680960" cy="4566901"/>
           </a:xfrm>
           <a:prstGeom prst="rect">
             <a:avLst/>
@@ -12191,7 +12191,7 @@
         <p:spPr>
           <a:xfrm>
             <a:off x="640080" y="1828800"/>
-            <a:ext cx="7315200" cy="4164685"/>
+            <a:ext cx="7315200" cy="4127806"/>
           </a:xfrm>
           <a:prstGeom prst="rect">
             <a:avLst/>
@@ -12572,7 +12572,7 @@
         <p:spPr>
           <a:xfrm>
             <a:off x="548640" y="1828800"/>
-            <a:ext cx="6400800" cy="4405601"/>
+            <a:ext cx="6400800" cy="4366588"/>
           </a:xfrm>
           <a:prstGeom prst="rect">
             <a:avLst/>
@@ -13532,7 +13532,7 @@
         <p:spPr>
           <a:xfrm>
             <a:off x="457200" y="1828800"/>
-            <a:ext cx="7132320" cy="4230508"/>
+            <a:ext cx="7132320" cy="4186305"/>
           </a:xfrm>
           <a:prstGeom prst="rect">
             <a:avLst/>
@@ -18122,7 +18122,7 @@
         <p:spPr>
           <a:xfrm>
             <a:off x="1828800" y="1783080"/>
-            <a:ext cx="7583515" cy="3703320"/>
+            <a:ext cx="8155626" cy="3703320"/>
           </a:xfrm>
           <a:prstGeom prst="rect">
             <a:avLst/>
@@ -23645,7 +23645,7 @@
         <p:spPr>
           <a:xfrm>
             <a:off x="457200" y="1828800"/>
-            <a:ext cx="6766560" cy="4577634"/>
+            <a:ext cx="6766560" cy="4537099"/>
           </a:xfrm>
           <a:prstGeom prst="rect">
             <a:avLst/>
@@ -24518,7 +24518,7 @@
         <p:spPr>
           <a:xfrm>
             <a:off x="365760" y="1783080"/>
-            <a:ext cx="6949440" cy="4425033"/>
+            <a:ext cx="6949440" cy="4206161"/>
           </a:xfrm>
           <a:prstGeom prst="rect">
             <a:avLst/>
@@ -25228,7 +25228,7 @@
         <p:spPr>
           <a:xfrm>
             <a:off x="640080" y="1828800"/>
-            <a:ext cx="7315200" cy="4407520"/>
+            <a:ext cx="7315200" cy="4368490"/>
           </a:xfrm>
           <a:prstGeom prst="rect">
             <a:avLst/>

</xml_diff>